<commit_message>
Update PSY 440 STUDENT 4- Health Promoting Behaviors.pptx
</commit_message>
<xml_diff>
--- a/PowerPoints/PSY 440 STUDENT 4- Health Promoting Behaviors.pptx
+++ b/PowerPoints/PSY 440 STUDENT 4- Health Promoting Behaviors.pptx
@@ -7759,7 +7759,7 @@
       </p:sp>
       <p:pic>
         <p:nvPicPr>
-          <p:cNvPr id="1026" name="Picture 2" descr="Sun protection infographic | healthdirect">
+          <p:cNvPr id="1026" name="Picture 2" descr="Infographic outlining five key sun protection steps labeled Slip, Slop, Slap, Seek, and Slide, each paired with corresponding icons and brief instructions such as wearing protective clothing, applying SPF30+ sunscreen, wearing a hat, seeking shade, and using sunglasses. The design uses pastel pink and blue panels with simple illustrations and includes a healthdirect logo and a note advising use of a symptom checker for sunburn concerns.">
             <a:extLst>
               <a:ext uri="{FF2B5EF4-FFF2-40B4-BE49-F238E27FC236}">
                 <a16:creationId xmlns:a16="http://schemas.microsoft.com/office/drawing/2014/main" id="{2AE5B177-918C-5911-E2D1-5BF7A3A7D8F4}"/>
@@ -7958,7 +7958,7 @@
       </p:sp>
       <p:pic>
         <p:nvPicPr>
-          <p:cNvPr id="8" name="Content Placeholder 7">
+          <p:cNvPr id="8" name="Content Placeholder 7" descr="Table showing healthy U.S.-style dietary patterns for adults ages 19-59, detailing daily or weekly amounts of food groups and subgroups across calorie levels from 1,600 to 3,000. Columns list calorie levels with corresponding servings of vegetables, fruits, grains, dairy, and protein foods, highlighting increases in whole grains, vegetables, and protein foods as calorie intake rises.">
             <a:extLst>
               <a:ext uri="{FF2B5EF4-FFF2-40B4-BE49-F238E27FC236}">
                 <a16:creationId xmlns:a16="http://schemas.microsoft.com/office/drawing/2014/main" id="{3560D538-F0AD-868B-D534-345A6544EA4D}"/>
@@ -8423,7 +8423,7 @@
       </p:sp>
       <p:pic>
         <p:nvPicPr>
-          <p:cNvPr id="8" name="Picture 2" descr="This is Your Brain on TrueDark® Twilights | TrueDark">
+          <p:cNvPr id="8" name="Picture 2" descr="Diagram illustrating five types of brainwaves categorized by frequency ranges and associated mental states. Faster brainwaves Gamma (31-120 Hz) and Beta (14-30 Hz) are linked to mental engagement and arousal, while slower brainwaves Alpha (9-13 Hz), Theta (4-8 Hz), and Delta (1-3 Hz) correspond to calmness and sleepiness, with each type represented by distinct colored boxes and waveform patterns.">
             <a:extLst>
               <a:ext uri="{FF2B5EF4-FFF2-40B4-BE49-F238E27FC236}">
                 <a16:creationId xmlns:a16="http://schemas.microsoft.com/office/drawing/2014/main" id="{6551DB2B-7393-780B-6F37-3CF31DDE6B93}"/>
@@ -8539,7 +8539,7 @@
       </p:sp>
       <p:pic>
         <p:nvPicPr>
-          <p:cNvPr id="6" name="Content Placeholder 5">
+          <p:cNvPr id="6" name="Content Placeholder 5" descr="Table categorizing sleep stages by description and associated brain wave types. It details five stages from awake with beta or gamma waves, through NREM stages 1 to 3 with alpha, theta, and delta waves, to REM sleep characterized by varied waves and muscle paralysis linked to memory and emotion processing.&#10;">
             <a:extLst>
               <a:ext uri="{FF2B5EF4-FFF2-40B4-BE49-F238E27FC236}">
                 <a16:creationId xmlns:a16="http://schemas.microsoft.com/office/drawing/2014/main" id="{61214E86-7330-6C00-1AC2-9B8A285FE902}"/>
@@ -11260,6 +11260,26 @@
 </file>
 
 <file path=customXml/item1.xml><?xml version="1.0" encoding="utf-8"?>
+<p:properties xmlns:p="http://schemas.microsoft.com/office/2006/metadata/properties" xmlns:xsi="http://www.w3.org/2001/XMLSchema-instance" xmlns:pc="http://schemas.microsoft.com/office/infopath/2007/PartnerControls">
+  <documentManagement>
+    <_ip_UnifiedCompliancePolicyUIAction xmlns="http://schemas.microsoft.com/sharepoint/v3" xsi:nil="true"/>
+    <Image xmlns="71af3243-3dd4-4a8d-8c0d-dd76da1f02a5">
+      <Url xsi:nil="true"/>
+      <Description xsi:nil="true"/>
+    </Image>
+    <Status xmlns="71af3243-3dd4-4a8d-8c0d-dd76da1f02a5">Not started</Status>
+    <Background xmlns="71af3243-3dd4-4a8d-8c0d-dd76da1f02a5">false</Background>
+    <_ip_UnifiedCompliancePolicyProperties xmlns="http://schemas.microsoft.com/sharepoint/v3" xsi:nil="true"/>
+    <ImageTagsTaxHTField xmlns="71af3243-3dd4-4a8d-8c0d-dd76da1f02a5">
+      <Terms xmlns="http://schemas.microsoft.com/office/infopath/2007/PartnerControls"/>
+    </ImageTagsTaxHTField>
+    <TaxCatchAll xmlns="230e9df3-be65-4c73-a93b-d1236ebd677e" xsi:nil="true"/>
+    <MediaServiceKeyPoints xmlns="71af3243-3dd4-4a8d-8c0d-dd76da1f02a5" xsi:nil="true"/>
+  </documentManagement>
+</p:properties>
+</file>
+
+<file path=customXml/item2.xml><?xml version="1.0" encoding="utf-8"?>
 <ct:contentTypeSchema xmlns:ct="http://schemas.microsoft.com/office/2006/metadata/contentType" xmlns:ma="http://schemas.microsoft.com/office/2006/metadata/properties/metaAttributes" ct:_="" ma:_="" ma:contentTypeName="Document" ma:contentTypeID="0x01010079F111ED35F8CC479449609E8A0923A6" ma:contentTypeVersion="28" ma:contentTypeDescription="Create a new document." ma:contentTypeScope="" ma:versionID="60f5a4f2d2b0abadcf532d48ebf9cb71">
   <xsd:schema xmlns:xsd="http://www.w3.org/2001/XMLSchema" xmlns:xs="http://www.w3.org/2001/XMLSchema" xmlns:p="http://schemas.microsoft.com/office/2006/metadata/properties" xmlns:ns1="http://schemas.microsoft.com/sharepoint/v3" xmlns:ns2="71af3243-3dd4-4a8d-8c0d-dd76da1f02a5" xmlns:ns3="16c05727-aa75-4e4a-9b5f-8a80a1165891" xmlns:ns4="230e9df3-be65-4c73-a93b-d1236ebd677e" targetNamespace="http://schemas.microsoft.com/office/2006/metadata/properties" ma:root="true" ma:fieldsID="7dd78129e6a1811f84807ad11c651531" ns1:_="" ns2:_="" ns3:_="" ns4:_="">
     <xsd:import namespace="http://schemas.microsoft.com/sharepoint/v3"/>
@@ -11571,26 +11591,6 @@
 </ct:contentTypeSchema>
 </file>
 
-<file path=customXml/item2.xml><?xml version="1.0" encoding="utf-8"?>
-<p:properties xmlns:p="http://schemas.microsoft.com/office/2006/metadata/properties" xmlns:xsi="http://www.w3.org/2001/XMLSchema-instance" xmlns:pc="http://schemas.microsoft.com/office/infopath/2007/PartnerControls">
-  <documentManagement>
-    <_ip_UnifiedCompliancePolicyUIAction xmlns="http://schemas.microsoft.com/sharepoint/v3" xsi:nil="true"/>
-    <Image xmlns="71af3243-3dd4-4a8d-8c0d-dd76da1f02a5">
-      <Url xsi:nil="true"/>
-      <Description xsi:nil="true"/>
-    </Image>
-    <Status xmlns="71af3243-3dd4-4a8d-8c0d-dd76da1f02a5">Not started</Status>
-    <Background xmlns="71af3243-3dd4-4a8d-8c0d-dd76da1f02a5">false</Background>
-    <_ip_UnifiedCompliancePolicyProperties xmlns="http://schemas.microsoft.com/sharepoint/v3" xsi:nil="true"/>
-    <ImageTagsTaxHTField xmlns="71af3243-3dd4-4a8d-8c0d-dd76da1f02a5">
-      <Terms xmlns="http://schemas.microsoft.com/office/infopath/2007/PartnerControls"/>
-    </ImageTagsTaxHTField>
-    <TaxCatchAll xmlns="230e9df3-be65-4c73-a93b-d1236ebd677e" xsi:nil="true"/>
-    <MediaServiceKeyPoints xmlns="71af3243-3dd4-4a8d-8c0d-dd76da1f02a5" xsi:nil="true"/>
-  </documentManagement>
-</p:properties>
-</file>
-
 <file path=customXml/item3.xml><?xml version="1.0" encoding="utf-8"?>
 <?mso-contentType ?>
 <FormTemplates xmlns="http://schemas.microsoft.com/sharepoint/v3/contenttype/forms">
@@ -11601,6 +11601,18 @@
 </file>
 
 <file path=customXml/itemProps1.xml><?xml version="1.0" encoding="utf-8"?>
+<ds:datastoreItem xmlns:ds="http://schemas.openxmlformats.org/officeDocument/2006/customXml" ds:itemID="{E3B37DAF-AFAF-4561-A80B-C76198EBD319}">
+  <ds:schemaRefs>
+    <ds:schemaRef ds:uri="http://schemas.microsoft.com/office/2006/metadata/properties"/>
+    <ds:schemaRef ds:uri="http://schemas.microsoft.com/office/infopath/2007/PartnerControls"/>
+    <ds:schemaRef ds:uri="http://schemas.microsoft.com/sharepoint/v3"/>
+    <ds:schemaRef ds:uri="71af3243-3dd4-4a8d-8c0d-dd76da1f02a5"/>
+    <ds:schemaRef ds:uri="230e9df3-be65-4c73-a93b-d1236ebd677e"/>
+  </ds:schemaRefs>
+</ds:datastoreItem>
+</file>
+
+<file path=customXml/itemProps2.xml><?xml version="1.0" encoding="utf-8"?>
 <ds:datastoreItem xmlns:ds="http://schemas.openxmlformats.org/officeDocument/2006/customXml" ds:itemID="{A29436BC-77AE-4AEE-A282-4E162A1CAA7D}">
   <ds:schemaRefs>
     <ds:schemaRef ds:uri="http://schemas.microsoft.com/office/2006/metadata/contentType"/>
@@ -11621,18 +11633,6 @@
 </ds:datastoreItem>
 </file>
 
-<file path=customXml/itemProps2.xml><?xml version="1.0" encoding="utf-8"?>
-<ds:datastoreItem xmlns:ds="http://schemas.openxmlformats.org/officeDocument/2006/customXml" ds:itemID="{E3B37DAF-AFAF-4561-A80B-C76198EBD319}">
-  <ds:schemaRefs>
-    <ds:schemaRef ds:uri="http://schemas.microsoft.com/office/2006/metadata/properties"/>
-    <ds:schemaRef ds:uri="http://schemas.microsoft.com/office/infopath/2007/PartnerControls"/>
-    <ds:schemaRef ds:uri="http://schemas.microsoft.com/sharepoint/v3"/>
-    <ds:schemaRef ds:uri="71af3243-3dd4-4a8d-8c0d-dd76da1f02a5"/>
-    <ds:schemaRef ds:uri="230e9df3-be65-4c73-a93b-d1236ebd677e"/>
-  </ds:schemaRefs>
-</ds:datastoreItem>
-</file>
-
 <file path=customXml/itemProps3.xml><?xml version="1.0" encoding="utf-8"?>
 <ds:datastoreItem xmlns:ds="http://schemas.openxmlformats.org/officeDocument/2006/customXml" ds:itemID="{5B665E41-66EB-401D-940D-8E7024721BE5}">
   <ds:schemaRefs>

</xml_diff>